<commit_message>
feat: Kreis unten rechts nicht mehr zeichnen
Auf Wunsch von Martin entfällt der leuchtende Ring auf allen Folien (Layouts und Fotofolien).
Die Fläche bleibt für die Videoeinblendung frei; check_deck meldet weiterhin Elemente darin.

Co-Authored-By: Claude Opus 5.5 <noreply@anthropic.com>
Claude-Session: https://claude.ai/code/session_01N9PVtcZKjnuaWVKADDArAR
</commit_message>
<xml_diff>
--- a/skill/flaesh-campus/assets/template/flaesh-campus-template.pptx
+++ b/skill/flaesh-campus/assets/template/flaesh-campus-template.pptx
@@ -2578,45 +2578,7 @@
       </p:pic>
       <p:sp>
         <p:nvSpPr>
-          <p:cNvPr id="5" name="zone-ring"/>
-          <p:cNvSpPr/>
-          <p:nvPr/>
-        </p:nvSpPr>
-        <p:spPr>
-          <a:xfrm>
-            <a:off x="9931400" y="4597400"/>
-            <a:ext cx="1905000" cy="1905000"/>
-          </a:xfrm>
-          <a:prstGeom prst="ellipse">
-            <a:avLst/>
-          </a:prstGeom>
-          <a:solidFill>
-            <a:srgbClr val="FFFFFF"/>
-          </a:solidFill>
-          <a:ln w="25400">
-            <a:solidFill>
-              <a:srgbClr val="00A5FF"/>
-            </a:solidFill>
-          </a:ln>
-          <a:effectLst>
-            <a:glow rad="292100">
-              <a:srgbClr val="00A5FF">
-                <a:alpha val="45000"/>
-              </a:srgbClr>
-            </a:glow>
-          </a:effectLst>
-        </p:spPr>
-        <p:txBody>
-          <a:bodyPr rtlCol="0" anchor="ctr"/>
-          <a:lstStyle/>
-          <a:p>
-            <a:pPr algn="ctr"/>
-          </a:p>
-        </p:txBody>
-      </p:sp>
-      <p:sp>
-        <p:nvSpPr>
-          <p:cNvPr id="6" name="Episode"/>
+          <p:cNvPr id="5" name="Episode"/>
           <p:cNvSpPr>
             <a:spLocks noGrp="1"/>
           </p:cNvSpPr>
@@ -2670,7 +2632,7 @@
       </p:sp>
       <p:sp>
         <p:nvSpPr>
-          <p:cNvPr id="7" name="Kicker"/>
+          <p:cNvPr id="6" name="Kicker"/>
           <p:cNvSpPr>
             <a:spLocks noGrp="1"/>
           </p:cNvSpPr>
@@ -2724,7 +2686,7 @@
       </p:sp>
       <p:sp>
         <p:nvSpPr>
-          <p:cNvPr id="8" name="Title"/>
+          <p:cNvPr id="7" name="Title"/>
           <p:cNvSpPr>
             <a:spLocks noGrp="1"/>
           </p:cNvSpPr>
@@ -2899,45 +2861,7 @@
       </p:pic>
       <p:sp>
         <p:nvSpPr>
-          <p:cNvPr id="5" name="zone-ring"/>
-          <p:cNvSpPr/>
-          <p:nvPr/>
-        </p:nvSpPr>
-        <p:spPr>
-          <a:xfrm>
-            <a:off x="9931400" y="4597400"/>
-            <a:ext cx="1905000" cy="1905000"/>
-          </a:xfrm>
-          <a:prstGeom prst="ellipse">
-            <a:avLst/>
-          </a:prstGeom>
-          <a:solidFill>
-            <a:srgbClr val="FFFFFF"/>
-          </a:solidFill>
-          <a:ln w="25400">
-            <a:solidFill>
-              <a:srgbClr val="00A5FF"/>
-            </a:solidFill>
-          </a:ln>
-          <a:effectLst>
-            <a:glow rad="292100">
-              <a:srgbClr val="00A5FF">
-                <a:alpha val="45000"/>
-              </a:srgbClr>
-            </a:glow>
-          </a:effectLst>
-        </p:spPr>
-        <p:txBody>
-          <a:bodyPr rtlCol="0" anchor="ctr"/>
-          <a:lstStyle/>
-          <a:p>
-            <a:pPr algn="ctr"/>
-          </a:p>
-        </p:txBody>
-      </p:sp>
-      <p:sp>
-        <p:nvSpPr>
-          <p:cNvPr id="6" name="Episode"/>
+          <p:cNvPr id="5" name="Episode"/>
           <p:cNvSpPr>
             <a:spLocks noGrp="1"/>
           </p:cNvSpPr>
@@ -2991,7 +2915,7 @@
       </p:sp>
       <p:sp>
         <p:nvSpPr>
-          <p:cNvPr id="7" name="Kicker"/>
+          <p:cNvPr id="6" name="Kicker"/>
           <p:cNvSpPr>
             <a:spLocks noGrp="1"/>
           </p:cNvSpPr>
@@ -3045,7 +2969,7 @@
       </p:sp>
       <p:sp>
         <p:nvSpPr>
-          <p:cNvPr id="8" name="Title"/>
+          <p:cNvPr id="7" name="Title"/>
           <p:cNvSpPr>
             <a:spLocks noGrp="1"/>
           </p:cNvSpPr>
@@ -3220,45 +3144,7 @@
       </p:pic>
       <p:sp>
         <p:nvSpPr>
-          <p:cNvPr id="5" name="zone-ring"/>
-          <p:cNvSpPr/>
-          <p:nvPr/>
-        </p:nvSpPr>
-        <p:spPr>
-          <a:xfrm>
-            <a:off x="9931400" y="4597400"/>
-            <a:ext cx="1905000" cy="1905000"/>
-          </a:xfrm>
-          <a:prstGeom prst="ellipse">
-            <a:avLst/>
-          </a:prstGeom>
-          <a:solidFill>
-            <a:srgbClr val="FFFFFF"/>
-          </a:solidFill>
-          <a:ln w="25400">
-            <a:solidFill>
-              <a:srgbClr val="00A5FF"/>
-            </a:solidFill>
-          </a:ln>
-          <a:effectLst>
-            <a:glow rad="292100">
-              <a:srgbClr val="00A5FF">
-                <a:alpha val="45000"/>
-              </a:srgbClr>
-            </a:glow>
-          </a:effectLst>
-        </p:spPr>
-        <p:txBody>
-          <a:bodyPr rtlCol="0" anchor="ctr"/>
-          <a:lstStyle/>
-          <a:p>
-            <a:pPr algn="ctr"/>
-          </a:p>
-        </p:txBody>
-      </p:sp>
-      <p:sp>
-        <p:nvSpPr>
-          <p:cNvPr id="6" name="Episode"/>
+          <p:cNvPr id="5" name="Episode"/>
           <p:cNvSpPr>
             <a:spLocks noGrp="1"/>
           </p:cNvSpPr>
@@ -3312,7 +3198,7 @@
       </p:sp>
       <p:sp>
         <p:nvSpPr>
-          <p:cNvPr id="7" name="Kicker"/>
+          <p:cNvPr id="6" name="Kicker"/>
           <p:cNvSpPr>
             <a:spLocks noGrp="1"/>
           </p:cNvSpPr>
@@ -3366,7 +3252,7 @@
       </p:sp>
       <p:sp>
         <p:nvSpPr>
-          <p:cNvPr id="8" name="Title"/>
+          <p:cNvPr id="7" name="Title"/>
           <p:cNvSpPr>
             <a:spLocks noGrp="1"/>
           </p:cNvSpPr>
@@ -3420,7 +3306,7 @@
       </p:sp>
       <p:sp>
         <p:nvSpPr>
-          <p:cNvPr id="9" name="Points"/>
+          <p:cNvPr id="8" name="Points"/>
           <p:cNvSpPr>
             <a:spLocks noGrp="1"/>
           </p:cNvSpPr>
@@ -3622,45 +3508,7 @@
       </p:pic>
       <p:sp>
         <p:nvSpPr>
-          <p:cNvPr id="5" name="zone-ring"/>
-          <p:cNvSpPr/>
-          <p:nvPr/>
-        </p:nvSpPr>
-        <p:spPr>
-          <a:xfrm>
-            <a:off x="9931400" y="4597400"/>
-            <a:ext cx="1905000" cy="1905000"/>
-          </a:xfrm>
-          <a:prstGeom prst="ellipse">
-            <a:avLst/>
-          </a:prstGeom>
-          <a:solidFill>
-            <a:srgbClr val="FFFFFF"/>
-          </a:solidFill>
-          <a:ln w="25400">
-            <a:solidFill>
-              <a:srgbClr val="00A5FF"/>
-            </a:solidFill>
-          </a:ln>
-          <a:effectLst>
-            <a:glow rad="292100">
-              <a:srgbClr val="00A5FF">
-                <a:alpha val="45000"/>
-              </a:srgbClr>
-            </a:glow>
-          </a:effectLst>
-        </p:spPr>
-        <p:txBody>
-          <a:bodyPr rtlCol="0" anchor="ctr"/>
-          <a:lstStyle/>
-          <a:p>
-            <a:pPr algn="ctr"/>
-          </a:p>
-        </p:txBody>
-      </p:sp>
-      <p:sp>
-        <p:nvSpPr>
-          <p:cNvPr id="6" name="Episode"/>
+          <p:cNvPr id="5" name="Episode"/>
           <p:cNvSpPr>
             <a:spLocks noGrp="1"/>
           </p:cNvSpPr>
@@ -3714,7 +3562,7 @@
       </p:sp>
       <p:sp>
         <p:nvSpPr>
-          <p:cNvPr id="7" name="Kicker"/>
+          <p:cNvPr id="6" name="Kicker"/>
           <p:cNvSpPr>
             <a:spLocks noGrp="1"/>
           </p:cNvSpPr>
@@ -3768,7 +3616,7 @@
       </p:sp>
       <p:sp>
         <p:nvSpPr>
-          <p:cNvPr id="8" name="Title"/>
+          <p:cNvPr id="7" name="Title"/>
           <p:cNvSpPr>
             <a:spLocks noGrp="1"/>
           </p:cNvSpPr>
@@ -4342,45 +4190,7 @@
       </p:pic>
       <p:sp>
         <p:nvSpPr>
-          <p:cNvPr id="5" name="zone-ring"/>
-          <p:cNvSpPr/>
-          <p:nvPr/>
-        </p:nvSpPr>
-        <p:spPr>
-          <a:xfrm>
-            <a:off x="9931400" y="4597400"/>
-            <a:ext cx="1905000" cy="1905000"/>
-          </a:xfrm>
-          <a:prstGeom prst="ellipse">
-            <a:avLst/>
-          </a:prstGeom>
-          <a:solidFill>
-            <a:srgbClr val="FFFFFF"/>
-          </a:solidFill>
-          <a:ln w="25400">
-            <a:solidFill>
-              <a:srgbClr val="00A5FF"/>
-            </a:solidFill>
-          </a:ln>
-          <a:effectLst>
-            <a:glow rad="292100">
-              <a:srgbClr val="00A5FF">
-                <a:alpha val="45000"/>
-              </a:srgbClr>
-            </a:glow>
-          </a:effectLst>
-        </p:spPr>
-        <p:txBody>
-          <a:bodyPr rtlCol="0" anchor="ctr"/>
-          <a:lstStyle/>
-          <a:p>
-            <a:pPr algn="ctr"/>
-          </a:p>
-        </p:txBody>
-      </p:sp>
-      <p:sp>
-        <p:nvSpPr>
-          <p:cNvPr id="6" name="Episode"/>
+          <p:cNvPr id="5" name="Episode"/>
           <p:cNvSpPr>
             <a:spLocks noGrp="1"/>
           </p:cNvSpPr>
@@ -4434,7 +4244,7 @@
       </p:sp>
       <p:sp>
         <p:nvSpPr>
-          <p:cNvPr id="7" name="Kicker"/>
+          <p:cNvPr id="6" name="Kicker"/>
           <p:cNvSpPr>
             <a:spLocks noGrp="1"/>
           </p:cNvSpPr>
@@ -4488,7 +4298,7 @@
       </p:sp>
       <p:sp>
         <p:nvSpPr>
-          <p:cNvPr id="8" name="Title"/>
+          <p:cNvPr id="7" name="Title"/>
           <p:cNvSpPr>
             <a:spLocks noGrp="1"/>
           </p:cNvSpPr>
@@ -4542,7 +4352,7 @@
       </p:sp>
       <p:sp>
         <p:nvSpPr>
-          <p:cNvPr id="9" name="PhotoBefore"/>
+          <p:cNvPr id="8" name="PhotoBefore"/>
           <p:cNvSpPr>
             <a:spLocks noGrp="1"/>
           </p:cNvSpPr>
@@ -4598,7 +4408,7 @@
       </p:sp>
       <p:sp>
         <p:nvSpPr>
-          <p:cNvPr id="10" name="PhotoAfter"/>
+          <p:cNvPr id="9" name="PhotoAfter"/>
           <p:cNvSpPr>
             <a:spLocks noGrp="1"/>
           </p:cNvSpPr>
@@ -4654,7 +4464,7 @@
       </p:sp>
       <p:sp>
         <p:nvSpPr>
-          <p:cNvPr id="11" name="LabelBefore"/>
+          <p:cNvPr id="10" name="LabelBefore"/>
           <p:cNvSpPr>
             <a:spLocks noGrp="1"/>
           </p:cNvSpPr>
@@ -4708,7 +4518,7 @@
       </p:sp>
       <p:sp>
         <p:nvSpPr>
-          <p:cNvPr id="12" name="LabelAfter"/>
+          <p:cNvPr id="11" name="LabelAfter"/>
           <p:cNvSpPr>
             <a:spLocks noGrp="1"/>
           </p:cNvSpPr>
@@ -4883,45 +4693,7 @@
       </p:pic>
       <p:sp>
         <p:nvSpPr>
-          <p:cNvPr id="5" name="zone-ring"/>
-          <p:cNvSpPr/>
-          <p:nvPr/>
-        </p:nvSpPr>
-        <p:spPr>
-          <a:xfrm>
-            <a:off x="9931400" y="4597400"/>
-            <a:ext cx="1905000" cy="1905000"/>
-          </a:xfrm>
-          <a:prstGeom prst="ellipse">
-            <a:avLst/>
-          </a:prstGeom>
-          <a:solidFill>
-            <a:srgbClr val="FFFFFF"/>
-          </a:solidFill>
-          <a:ln w="25400">
-            <a:solidFill>
-              <a:srgbClr val="00A5FF"/>
-            </a:solidFill>
-          </a:ln>
-          <a:effectLst>
-            <a:glow rad="292100">
-              <a:srgbClr val="00A5FF">
-                <a:alpha val="45000"/>
-              </a:srgbClr>
-            </a:glow>
-          </a:effectLst>
-        </p:spPr>
-        <p:txBody>
-          <a:bodyPr rtlCol="0" anchor="ctr"/>
-          <a:lstStyle/>
-          <a:p>
-            <a:pPr algn="ctr"/>
-          </a:p>
-        </p:txBody>
-      </p:sp>
-      <p:sp>
-        <p:nvSpPr>
-          <p:cNvPr id="6" name="Episode"/>
+          <p:cNvPr id="5" name="Episode"/>
           <p:cNvSpPr>
             <a:spLocks noGrp="1"/>
           </p:cNvSpPr>
@@ -4975,7 +4747,7 @@
       </p:sp>
       <p:sp>
         <p:nvSpPr>
-          <p:cNvPr id="7" name="Kicker"/>
+          <p:cNvPr id="6" name="Kicker"/>
           <p:cNvSpPr>
             <a:spLocks noGrp="1"/>
           </p:cNvSpPr>
@@ -5029,7 +4801,7 @@
       </p:sp>
       <p:sp>
         <p:nvSpPr>
-          <p:cNvPr id="8" name="Title"/>
+          <p:cNvPr id="7" name="Title"/>
           <p:cNvSpPr>
             <a:spLocks noGrp="1"/>
           </p:cNvSpPr>
@@ -5083,7 +4855,7 @@
       </p:sp>
       <p:sp>
         <p:nvSpPr>
-          <p:cNvPr id="9" name="Photo"/>
+          <p:cNvPr id="8" name="Photo"/>
           <p:cNvSpPr>
             <a:spLocks noGrp="1"/>
           </p:cNvSpPr>
@@ -5260,45 +5032,7 @@
       </p:pic>
       <p:sp>
         <p:nvSpPr>
-          <p:cNvPr id="5" name="zone-ring"/>
-          <p:cNvSpPr/>
-          <p:nvPr/>
-        </p:nvSpPr>
-        <p:spPr>
-          <a:xfrm>
-            <a:off x="9931400" y="4597400"/>
-            <a:ext cx="1905000" cy="1905000"/>
-          </a:xfrm>
-          <a:prstGeom prst="ellipse">
-            <a:avLst/>
-          </a:prstGeom>
-          <a:solidFill>
-            <a:srgbClr val="FFFFFF"/>
-          </a:solidFill>
-          <a:ln w="25400">
-            <a:solidFill>
-              <a:srgbClr val="00A5FF"/>
-            </a:solidFill>
-          </a:ln>
-          <a:effectLst>
-            <a:glow rad="292100">
-              <a:srgbClr val="00A5FF">
-                <a:alpha val="45000"/>
-              </a:srgbClr>
-            </a:glow>
-          </a:effectLst>
-        </p:spPr>
-        <p:txBody>
-          <a:bodyPr rtlCol="0" anchor="ctr"/>
-          <a:lstStyle/>
-          <a:p>
-            <a:pPr algn="ctr"/>
-          </a:p>
-        </p:txBody>
-      </p:sp>
-      <p:sp>
-        <p:nvSpPr>
-          <p:cNvPr id="6" name="Episode"/>
+          <p:cNvPr id="5" name="Episode"/>
           <p:cNvSpPr>
             <a:spLocks noGrp="1"/>
           </p:cNvSpPr>
@@ -5352,7 +5086,7 @@
       </p:sp>
       <p:sp>
         <p:nvSpPr>
-          <p:cNvPr id="7" name="Kicker"/>
+          <p:cNvPr id="6" name="Kicker"/>
           <p:cNvSpPr>
             <a:spLocks noGrp="1"/>
           </p:cNvSpPr>
@@ -5406,7 +5140,7 @@
       </p:sp>
       <p:sp>
         <p:nvSpPr>
-          <p:cNvPr id="8" name="Title"/>
+          <p:cNvPr id="7" name="Title"/>
           <p:cNvSpPr>
             <a:spLocks noGrp="1"/>
           </p:cNvSpPr>
@@ -5460,7 +5194,7 @@
       </p:sp>
       <p:sp>
         <p:nvSpPr>
-          <p:cNvPr id="9" name="Story"/>
+          <p:cNvPr id="8" name="Story"/>
           <p:cNvSpPr>
             <a:spLocks noGrp="1"/>
           </p:cNvSpPr>
@@ -5635,45 +5369,7 @@
       </p:pic>
       <p:sp>
         <p:nvSpPr>
-          <p:cNvPr id="5" name="zone-ring"/>
-          <p:cNvSpPr/>
-          <p:nvPr/>
-        </p:nvSpPr>
-        <p:spPr>
-          <a:xfrm>
-            <a:off x="9931400" y="4597400"/>
-            <a:ext cx="1905000" cy="1905000"/>
-          </a:xfrm>
-          <a:prstGeom prst="ellipse">
-            <a:avLst/>
-          </a:prstGeom>
-          <a:solidFill>
-            <a:srgbClr val="232C31"/>
-          </a:solidFill>
-          <a:ln w="25400">
-            <a:solidFill>
-              <a:srgbClr val="00A5FF"/>
-            </a:solidFill>
-          </a:ln>
-          <a:effectLst>
-            <a:glow rad="381000">
-              <a:srgbClr val="00A5FF">
-                <a:alpha val="55000"/>
-              </a:srgbClr>
-            </a:glow>
-          </a:effectLst>
-        </p:spPr>
-        <p:txBody>
-          <a:bodyPr rtlCol="0" anchor="ctr"/>
-          <a:lstStyle/>
-          <a:p>
-            <a:pPr algn="ctr"/>
-          </a:p>
-        </p:txBody>
-      </p:sp>
-      <p:sp>
-        <p:nvSpPr>
-          <p:cNvPr id="6" name="Episode"/>
+          <p:cNvPr id="5" name="Episode"/>
           <p:cNvSpPr>
             <a:spLocks noGrp="1"/>
           </p:cNvSpPr>
@@ -5727,7 +5423,7 @@
       </p:sp>
       <p:sp>
         <p:nvSpPr>
-          <p:cNvPr id="7" name="Kicker"/>
+          <p:cNvPr id="6" name="Kicker"/>
           <p:cNvSpPr>
             <a:spLocks noGrp="1"/>
           </p:cNvSpPr>
@@ -5781,7 +5477,7 @@
       </p:sp>
       <p:sp>
         <p:nvSpPr>
-          <p:cNvPr id="8" name="Question"/>
+          <p:cNvPr id="7" name="Question"/>
           <p:cNvSpPr>
             <a:spLocks noGrp="1"/>
           </p:cNvSpPr>
@@ -6004,45 +5700,7 @@
       </p:pic>
       <p:sp>
         <p:nvSpPr>
-          <p:cNvPr id="6" name="zone-ring"/>
-          <p:cNvSpPr/>
-          <p:nvPr/>
-        </p:nvSpPr>
-        <p:spPr>
-          <a:xfrm>
-            <a:off x="9931400" y="4597400"/>
-            <a:ext cx="1905000" cy="1905000"/>
-          </a:xfrm>
-          <a:prstGeom prst="ellipse">
-            <a:avLst/>
-          </a:prstGeom>
-          <a:solidFill>
-            <a:srgbClr val="232C31"/>
-          </a:solidFill>
-          <a:ln w="25400">
-            <a:solidFill>
-              <a:srgbClr val="00A5FF"/>
-            </a:solidFill>
-          </a:ln>
-          <a:effectLst>
-            <a:glow rad="381000">
-              <a:srgbClr val="00A5FF">
-                <a:alpha val="55000"/>
-              </a:srgbClr>
-            </a:glow>
-          </a:effectLst>
-        </p:spPr>
-        <p:txBody>
-          <a:bodyPr rtlCol="0" anchor="ctr"/>
-          <a:lstStyle/>
-          <a:p>
-            <a:pPr algn="ctr"/>
-          </a:p>
-        </p:txBody>
-      </p:sp>
-      <p:sp>
-        <p:nvSpPr>
-          <p:cNvPr id="7" name="Episode"/>
+          <p:cNvPr id="6" name="Episode"/>
           <p:cNvSpPr>
             <a:spLocks noGrp="1"/>
           </p:cNvSpPr>
@@ -6096,7 +5754,7 @@
       </p:sp>
       <p:sp>
         <p:nvSpPr>
-          <p:cNvPr id="8" name="Number"/>
+          <p:cNvPr id="7" name="Number"/>
           <p:cNvSpPr>
             <a:spLocks noGrp="1"/>
           </p:cNvSpPr>
@@ -6160,7 +5818,7 @@
       </p:sp>
       <p:sp>
         <p:nvSpPr>
-          <p:cNvPr id="9" name="Kicker"/>
+          <p:cNvPr id="8" name="Kicker"/>
           <p:cNvSpPr>
             <a:spLocks noGrp="1"/>
           </p:cNvSpPr>
@@ -6214,7 +5872,7 @@
       </p:sp>
       <p:sp>
         <p:nvSpPr>
-          <p:cNvPr id="10" name="Title"/>
+          <p:cNvPr id="9" name="Title"/>
           <p:cNvSpPr>
             <a:spLocks noGrp="1"/>
           </p:cNvSpPr>
@@ -6271,7 +5929,7 @@
       </p:sp>
       <p:sp>
         <p:nvSpPr>
-          <p:cNvPr id="11" name="Line"/>
+          <p:cNvPr id="10" name="Line"/>
           <p:cNvSpPr>
             <a:spLocks noGrp="1"/>
           </p:cNvSpPr>
@@ -6446,45 +6104,7 @@
       </p:pic>
       <p:sp>
         <p:nvSpPr>
-          <p:cNvPr id="5" name="zone-ring"/>
-          <p:cNvSpPr/>
-          <p:nvPr/>
-        </p:nvSpPr>
-        <p:spPr>
-          <a:xfrm>
-            <a:off x="9931400" y="4597400"/>
-            <a:ext cx="1905000" cy="1905000"/>
-          </a:xfrm>
-          <a:prstGeom prst="ellipse">
-            <a:avLst/>
-          </a:prstGeom>
-          <a:solidFill>
-            <a:srgbClr val="232C31"/>
-          </a:solidFill>
-          <a:ln w="25400">
-            <a:solidFill>
-              <a:srgbClr val="00A5FF"/>
-            </a:solidFill>
-          </a:ln>
-          <a:effectLst>
-            <a:glow rad="381000">
-              <a:srgbClr val="00A5FF">
-                <a:alpha val="55000"/>
-              </a:srgbClr>
-            </a:glow>
-          </a:effectLst>
-        </p:spPr>
-        <p:txBody>
-          <a:bodyPr rtlCol="0" anchor="ctr"/>
-          <a:lstStyle/>
-          <a:p>
-            <a:pPr algn="ctr"/>
-          </a:p>
-        </p:txBody>
-      </p:sp>
-      <p:sp>
-        <p:nvSpPr>
-          <p:cNvPr id="6" name="truth-card"/>
+          <p:cNvPr id="5" name="truth-card"/>
           <p:cNvSpPr/>
           <p:nvPr/>
         </p:nvSpPr>
@@ -6515,7 +6135,7 @@
       </p:sp>
       <p:sp>
         <p:nvSpPr>
-          <p:cNvPr id="7" name="answer-card"/>
+          <p:cNvPr id="6" name="answer-card"/>
           <p:cNvSpPr/>
           <p:nvPr/>
         </p:nvSpPr>
@@ -6555,7 +6175,7 @@
       </p:sp>
       <p:sp>
         <p:nvSpPr>
-          <p:cNvPr id="8" name="Episode"/>
+          <p:cNvPr id="7" name="Episode"/>
           <p:cNvSpPr>
             <a:spLocks noGrp="1"/>
           </p:cNvSpPr>
@@ -6609,7 +6229,7 @@
       </p:sp>
       <p:sp>
         <p:nvSpPr>
-          <p:cNvPr id="9" name="Kicker"/>
+          <p:cNvPr id="8" name="Kicker"/>
           <p:cNvSpPr>
             <a:spLocks noGrp="1"/>
           </p:cNvSpPr>
@@ -6663,7 +6283,7 @@
       </p:sp>
       <p:sp>
         <p:nvSpPr>
-          <p:cNvPr id="10" name="Quote"/>
+          <p:cNvPr id="9" name="Quote"/>
           <p:cNvSpPr>
             <a:spLocks noGrp="1"/>
           </p:cNvSpPr>
@@ -6717,7 +6337,7 @@
       </p:sp>
       <p:sp>
         <p:nvSpPr>
-          <p:cNvPr id="11" name="TruthLabel"/>
+          <p:cNvPr id="10" name="TruthLabel"/>
           <p:cNvSpPr>
             <a:spLocks noGrp="1"/>
           </p:cNvSpPr>
@@ -6771,7 +6391,7 @@
       </p:sp>
       <p:sp>
         <p:nvSpPr>
-          <p:cNvPr id="12" name="TruthText"/>
+          <p:cNvPr id="11" name="TruthText"/>
           <p:cNvSpPr>
             <a:spLocks noGrp="1"/>
           </p:cNvSpPr>
@@ -6825,7 +6445,7 @@
       </p:sp>
       <p:sp>
         <p:nvSpPr>
-          <p:cNvPr id="13" name="AnswerLabel"/>
+          <p:cNvPr id="12" name="AnswerLabel"/>
           <p:cNvSpPr>
             <a:spLocks noGrp="1"/>
           </p:cNvSpPr>
@@ -6879,7 +6499,7 @@
       </p:sp>
       <p:sp>
         <p:nvSpPr>
-          <p:cNvPr id="14" name="AnswerText"/>
+          <p:cNvPr id="13" name="AnswerText"/>
           <p:cNvSpPr>
             <a:spLocks noGrp="1"/>
           </p:cNvSpPr>
@@ -7054,45 +6674,7 @@
       </p:pic>
       <p:sp>
         <p:nvSpPr>
-          <p:cNvPr id="5" name="zone-ring"/>
-          <p:cNvSpPr/>
-          <p:nvPr/>
-        </p:nvSpPr>
-        <p:spPr>
-          <a:xfrm>
-            <a:off x="9931400" y="4597400"/>
-            <a:ext cx="1905000" cy="1905000"/>
-          </a:xfrm>
-          <a:prstGeom prst="ellipse">
-            <a:avLst/>
-          </a:prstGeom>
-          <a:solidFill>
-            <a:srgbClr val="232C31"/>
-          </a:solidFill>
-          <a:ln w="25400">
-            <a:solidFill>
-              <a:srgbClr val="00A5FF"/>
-            </a:solidFill>
-          </a:ln>
-          <a:effectLst>
-            <a:glow rad="381000">
-              <a:srgbClr val="00A5FF">
-                <a:alpha val="55000"/>
-              </a:srgbClr>
-            </a:glow>
-          </a:effectLst>
-        </p:spPr>
-        <p:txBody>
-          <a:bodyPr rtlCol="0" anchor="ctr"/>
-          <a:lstStyle/>
-          <a:p>
-            <a:pPr algn="ctr"/>
-          </a:p>
-        </p:txBody>
-      </p:sp>
-      <p:sp>
-        <p:nvSpPr>
-          <p:cNvPr id="6" name="next-card"/>
+          <p:cNvPr id="5" name="next-card"/>
           <p:cNvSpPr/>
           <p:nvPr/>
         </p:nvSpPr>
@@ -7132,7 +6714,7 @@
       </p:sp>
       <p:sp>
         <p:nvSpPr>
-          <p:cNvPr id="7" name="Episode"/>
+          <p:cNvPr id="6" name="Episode"/>
           <p:cNvSpPr>
             <a:spLocks noGrp="1"/>
           </p:cNvSpPr>
@@ -7186,7 +6768,7 @@
       </p:sp>
       <p:sp>
         <p:nvSpPr>
-          <p:cNvPr id="8" name="Kicker"/>
+          <p:cNvPr id="7" name="Kicker"/>
           <p:cNvSpPr>
             <a:spLocks noGrp="1"/>
           </p:cNvSpPr>
@@ -7240,7 +6822,7 @@
       </p:sp>
       <p:sp>
         <p:nvSpPr>
-          <p:cNvPr id="9" name="Title"/>
+          <p:cNvPr id="8" name="Title"/>
           <p:cNvSpPr>
             <a:spLocks noGrp="1"/>
           </p:cNvSpPr>
@@ -7294,7 +6876,7 @@
       </p:sp>
       <p:sp>
         <p:nvSpPr>
-          <p:cNvPr id="10" name="NextLabel"/>
+          <p:cNvPr id="9" name="NextLabel"/>
           <p:cNvSpPr>
             <a:spLocks noGrp="1"/>
           </p:cNvSpPr>
@@ -7348,7 +6930,7 @@
       </p:sp>
       <p:sp>
         <p:nvSpPr>
-          <p:cNvPr id="11" name="NextTitle"/>
+          <p:cNvPr id="10" name="NextTitle"/>
           <p:cNvSpPr>
             <a:spLocks noGrp="1"/>
           </p:cNvSpPr>
@@ -7402,7 +6984,7 @@
       </p:sp>
       <p:sp>
         <p:nvSpPr>
-          <p:cNvPr id="12" name="NextText"/>
+          <p:cNvPr id="11" name="NextText"/>
           <p:cNvSpPr>
             <a:spLocks noGrp="1"/>
           </p:cNvSpPr>
@@ -7577,45 +7159,7 @@
       </p:pic>
       <p:sp>
         <p:nvSpPr>
-          <p:cNvPr id="5" name="zone-ring"/>
-          <p:cNvSpPr/>
-          <p:nvPr/>
-        </p:nvSpPr>
-        <p:spPr>
-          <a:xfrm>
-            <a:off x="9931400" y="4597400"/>
-            <a:ext cx="1905000" cy="1905000"/>
-          </a:xfrm>
-          <a:prstGeom prst="ellipse">
-            <a:avLst/>
-          </a:prstGeom>
-          <a:solidFill>
-            <a:srgbClr val="FFFFFF"/>
-          </a:solidFill>
-          <a:ln w="25400">
-            <a:solidFill>
-              <a:srgbClr val="00A5FF"/>
-            </a:solidFill>
-          </a:ln>
-          <a:effectLst>
-            <a:glow rad="292100">
-              <a:srgbClr val="00A5FF">
-                <a:alpha val="45000"/>
-              </a:srgbClr>
-            </a:glow>
-          </a:effectLst>
-        </p:spPr>
-        <p:txBody>
-          <a:bodyPr rtlCol="0" anchor="ctr"/>
-          <a:lstStyle/>
-          <a:p>
-            <a:pPr algn="ctr"/>
-          </a:p>
-        </p:txBody>
-      </p:sp>
-      <p:sp>
-        <p:nvSpPr>
-          <p:cNvPr id="6" name="Episode"/>
+          <p:cNvPr id="5" name="Episode"/>
           <p:cNvSpPr>
             <a:spLocks noGrp="1"/>
           </p:cNvSpPr>
@@ -7669,7 +7213,7 @@
       </p:sp>
       <p:sp>
         <p:nvSpPr>
-          <p:cNvPr id="7" name="Kicker"/>
+          <p:cNvPr id="6" name="Kicker"/>
           <p:cNvSpPr>
             <a:spLocks noGrp="1"/>
           </p:cNvSpPr>
@@ -7723,7 +7267,7 @@
       </p:sp>
       <p:sp>
         <p:nvSpPr>
-          <p:cNvPr id="8" name="Title"/>
+          <p:cNvPr id="7" name="Title"/>
           <p:cNvSpPr>
             <a:spLocks noGrp="1"/>
           </p:cNvSpPr>
@@ -7777,7 +7321,7 @@
       </p:sp>
       <p:sp>
         <p:nvSpPr>
-          <p:cNvPr id="9" name="Points"/>
+          <p:cNvPr id="8" name="Points"/>
           <p:cNvSpPr>
             <a:spLocks noGrp="1"/>
           </p:cNvSpPr>
@@ -7979,45 +7523,7 @@
       </p:pic>
       <p:sp>
         <p:nvSpPr>
-          <p:cNvPr id="5" name="zone-ring"/>
-          <p:cNvSpPr/>
-          <p:nvPr/>
-        </p:nvSpPr>
-        <p:spPr>
-          <a:xfrm>
-            <a:off x="9931400" y="4597400"/>
-            <a:ext cx="1905000" cy="1905000"/>
-          </a:xfrm>
-          <a:prstGeom prst="ellipse">
-            <a:avLst/>
-          </a:prstGeom>
-          <a:solidFill>
-            <a:srgbClr val="FFFFFF"/>
-          </a:solidFill>
-          <a:ln w="25400">
-            <a:solidFill>
-              <a:srgbClr val="00A5FF"/>
-            </a:solidFill>
-          </a:ln>
-          <a:effectLst>
-            <a:glow rad="292100">
-              <a:srgbClr val="00A5FF">
-                <a:alpha val="45000"/>
-              </a:srgbClr>
-            </a:glow>
-          </a:effectLst>
-        </p:spPr>
-        <p:txBody>
-          <a:bodyPr rtlCol="0" anchor="ctr"/>
-          <a:lstStyle/>
-          <a:p>
-            <a:pPr algn="ctr"/>
-          </a:p>
-        </p:txBody>
-      </p:sp>
-      <p:sp>
-        <p:nvSpPr>
-          <p:cNvPr id="6" name="Episode"/>
+          <p:cNvPr id="5" name="Episode"/>
           <p:cNvSpPr>
             <a:spLocks noGrp="1"/>
           </p:cNvSpPr>
@@ -8071,7 +7577,7 @@
       </p:sp>
       <p:sp>
         <p:nvSpPr>
-          <p:cNvPr id="7" name="Kicker"/>
+          <p:cNvPr id="6" name="Kicker"/>
           <p:cNvSpPr>
             <a:spLocks noGrp="1"/>
           </p:cNvSpPr>
@@ -8125,7 +7631,7 @@
       </p:sp>
       <p:sp>
         <p:nvSpPr>
-          <p:cNvPr id="8" name="Title"/>
+          <p:cNvPr id="7" name="Title"/>
           <p:cNvSpPr>
             <a:spLocks noGrp="1"/>
           </p:cNvSpPr>
@@ -8179,7 +7685,7 @@
       </p:sp>
       <p:sp>
         <p:nvSpPr>
-          <p:cNvPr id="9" name="Points"/>
+          <p:cNvPr id="8" name="Points"/>
           <p:cNvSpPr>
             <a:spLocks noGrp="1"/>
           </p:cNvSpPr>
@@ -8260,7 +7766,7 @@
       </p:sp>
       <p:sp>
         <p:nvSpPr>
-          <p:cNvPr id="10" name="Photo"/>
+          <p:cNvPr id="9" name="Photo"/>
           <p:cNvSpPr>
             <a:spLocks noGrp="1"/>
           </p:cNvSpPr>
@@ -8316,7 +7822,7 @@
       </p:sp>
       <p:sp>
         <p:nvSpPr>
-          <p:cNvPr id="11" name="Caption"/>
+          <p:cNvPr id="10" name="Caption"/>
           <p:cNvSpPr>
             <a:spLocks noGrp="1"/>
           </p:cNvSpPr>
@@ -8491,45 +7997,7 @@
       </p:pic>
       <p:sp>
         <p:nvSpPr>
-          <p:cNvPr id="5" name="zone-ring"/>
-          <p:cNvSpPr/>
-          <p:nvPr/>
-        </p:nvSpPr>
-        <p:spPr>
-          <a:xfrm>
-            <a:off x="9931400" y="4597400"/>
-            <a:ext cx="1905000" cy="1905000"/>
-          </a:xfrm>
-          <a:prstGeom prst="ellipse">
-            <a:avLst/>
-          </a:prstGeom>
-          <a:solidFill>
-            <a:srgbClr val="FFFFFF"/>
-          </a:solidFill>
-          <a:ln w="25400">
-            <a:solidFill>
-              <a:srgbClr val="00A5FF"/>
-            </a:solidFill>
-          </a:ln>
-          <a:effectLst>
-            <a:glow rad="292100">
-              <a:srgbClr val="00A5FF">
-                <a:alpha val="45000"/>
-              </a:srgbClr>
-            </a:glow>
-          </a:effectLst>
-        </p:spPr>
-        <p:txBody>
-          <a:bodyPr rtlCol="0" anchor="ctr"/>
-          <a:lstStyle/>
-          <a:p>
-            <a:pPr algn="ctr"/>
-          </a:p>
-        </p:txBody>
-      </p:sp>
-      <p:sp>
-        <p:nvSpPr>
-          <p:cNvPr id="6" name="Episode"/>
+          <p:cNvPr id="5" name="Episode"/>
           <p:cNvSpPr>
             <a:spLocks noGrp="1"/>
           </p:cNvSpPr>
@@ -8583,7 +8051,7 @@
       </p:sp>
       <p:sp>
         <p:nvSpPr>
-          <p:cNvPr id="7" name="Kicker"/>
+          <p:cNvPr id="6" name="Kicker"/>
           <p:cNvSpPr>
             <a:spLocks noGrp="1"/>
           </p:cNvSpPr>
@@ -8637,7 +8105,7 @@
       </p:sp>
       <p:sp>
         <p:nvSpPr>
-          <p:cNvPr id="8" name="Title"/>
+          <p:cNvPr id="7" name="Title"/>
           <p:cNvSpPr>
             <a:spLocks noGrp="1"/>
           </p:cNvSpPr>
@@ -8691,7 +8159,7 @@
       </p:sp>
       <p:sp>
         <p:nvSpPr>
-          <p:cNvPr id="9" name="Points"/>
+          <p:cNvPr id="8" name="Points"/>
           <p:cNvSpPr>
             <a:spLocks noGrp="1"/>
           </p:cNvSpPr>
@@ -8893,45 +8361,7 @@
       </p:pic>
       <p:sp>
         <p:nvSpPr>
-          <p:cNvPr id="5" name="zone-ring"/>
-          <p:cNvSpPr/>
-          <p:nvPr/>
-        </p:nvSpPr>
-        <p:spPr>
-          <a:xfrm>
-            <a:off x="9931400" y="4597400"/>
-            <a:ext cx="1905000" cy="1905000"/>
-          </a:xfrm>
-          <a:prstGeom prst="ellipse">
-            <a:avLst/>
-          </a:prstGeom>
-          <a:solidFill>
-            <a:srgbClr val="FFFFFF"/>
-          </a:solidFill>
-          <a:ln w="25400">
-            <a:solidFill>
-              <a:srgbClr val="00A5FF"/>
-            </a:solidFill>
-          </a:ln>
-          <a:effectLst>
-            <a:glow rad="292100">
-              <a:srgbClr val="00A5FF">
-                <a:alpha val="45000"/>
-              </a:srgbClr>
-            </a:glow>
-          </a:effectLst>
-        </p:spPr>
-        <p:txBody>
-          <a:bodyPr rtlCol="0" anchor="ctr"/>
-          <a:lstStyle/>
-          <a:p>
-            <a:pPr algn="ctr"/>
-          </a:p>
-        </p:txBody>
-      </p:sp>
-      <p:sp>
-        <p:nvSpPr>
-          <p:cNvPr id="6" name="Episode"/>
+          <p:cNvPr id="5" name="Episode"/>
           <p:cNvSpPr>
             <a:spLocks noGrp="1"/>
           </p:cNvSpPr>
@@ -8985,7 +8415,7 @@
       </p:sp>
       <p:sp>
         <p:nvSpPr>
-          <p:cNvPr id="7" name="Kicker"/>
+          <p:cNvPr id="6" name="Kicker"/>
           <p:cNvSpPr>
             <a:spLocks noGrp="1"/>
           </p:cNvSpPr>
@@ -9039,7 +8469,7 @@
       </p:sp>
       <p:sp>
         <p:nvSpPr>
-          <p:cNvPr id="8" name="Big"/>
+          <p:cNvPr id="7" name="Big"/>
           <p:cNvSpPr>
             <a:spLocks noGrp="1"/>
           </p:cNvSpPr>
@@ -9096,7 +8526,7 @@
       </p:sp>
       <p:sp>
         <p:nvSpPr>
-          <p:cNvPr id="9" name="Statement"/>
+          <p:cNvPr id="8" name="Statement"/>
           <p:cNvSpPr>
             <a:spLocks noGrp="1"/>
           </p:cNvSpPr>
@@ -9150,7 +8580,7 @@
       </p:sp>
       <p:sp>
         <p:nvSpPr>
-          <p:cNvPr id="10" name="Text"/>
+          <p:cNvPr id="9" name="Text"/>
           <p:cNvSpPr>
             <a:spLocks noGrp="1"/>
           </p:cNvSpPr>
@@ -9325,45 +8755,7 @@
       </p:pic>
       <p:sp>
         <p:nvSpPr>
-          <p:cNvPr id="5" name="zone-ring"/>
-          <p:cNvSpPr/>
-          <p:nvPr/>
-        </p:nvSpPr>
-        <p:spPr>
-          <a:xfrm>
-            <a:off x="9931400" y="4597400"/>
-            <a:ext cx="1905000" cy="1905000"/>
-          </a:xfrm>
-          <a:prstGeom prst="ellipse">
-            <a:avLst/>
-          </a:prstGeom>
-          <a:solidFill>
-            <a:srgbClr val="FFFFFF"/>
-          </a:solidFill>
-          <a:ln w="25400">
-            <a:solidFill>
-              <a:srgbClr val="00A5FF"/>
-            </a:solidFill>
-          </a:ln>
-          <a:effectLst>
-            <a:glow rad="292100">
-              <a:srgbClr val="00A5FF">
-                <a:alpha val="45000"/>
-              </a:srgbClr>
-            </a:glow>
-          </a:effectLst>
-        </p:spPr>
-        <p:txBody>
-          <a:bodyPr rtlCol="0" anchor="ctr"/>
-          <a:lstStyle/>
-          <a:p>
-            <a:pPr algn="ctr"/>
-          </a:p>
-        </p:txBody>
-      </p:sp>
-      <p:sp>
-        <p:nvSpPr>
-          <p:cNvPr id="6" name="Episode"/>
+          <p:cNvPr id="5" name="Episode"/>
           <p:cNvSpPr>
             <a:spLocks noGrp="1"/>
           </p:cNvSpPr>
@@ -9417,7 +8809,7 @@
       </p:sp>
       <p:sp>
         <p:nvSpPr>
-          <p:cNvPr id="7" name="Kicker"/>
+          <p:cNvPr id="6" name="Kicker"/>
           <p:cNvSpPr>
             <a:spLocks noGrp="1"/>
           </p:cNvSpPr>
@@ -9471,7 +8863,7 @@
       </p:sp>
       <p:sp>
         <p:nvSpPr>
-          <p:cNvPr id="8" name="Title"/>
+          <p:cNvPr id="7" name="Title"/>
           <p:cNvSpPr>
             <a:spLocks noGrp="1"/>
           </p:cNvSpPr>
@@ -15208,45 +14600,7 @@
       </p:sp>
       <p:sp>
         <p:nvSpPr>
-          <p:cNvPr id="11" name="zone-ring-top"/>
-          <p:cNvSpPr/>
-          <p:nvPr/>
-        </p:nvSpPr>
-        <p:spPr>
-          <a:xfrm>
-            <a:off x="9931400" y="4597400"/>
-            <a:ext cx="1905000" cy="1905000"/>
-          </a:xfrm>
-          <a:prstGeom prst="ellipse">
-            <a:avLst/>
-          </a:prstGeom>
-          <a:solidFill>
-            <a:srgbClr val="232C31"/>
-          </a:solidFill>
-          <a:ln w="25400">
-            <a:solidFill>
-              <a:srgbClr val="00A5FF"/>
-            </a:solidFill>
-          </a:ln>
-          <a:effectLst>
-            <a:glow rad="381000">
-              <a:srgbClr val="00A5FF">
-                <a:alpha val="55000"/>
-              </a:srgbClr>
-            </a:glow>
-          </a:effectLst>
-        </p:spPr>
-        <p:txBody>
-          <a:bodyPr rtlCol="0" anchor="ctr"/>
-          <a:lstStyle/>
-          <a:p>
-            <a:pPr algn="ctr"/>
-          </a:p>
-        </p:txBody>
-      </p:sp>
-      <p:sp>
-        <p:nvSpPr>
-          <p:cNvPr id="12" name="rail-line"/>
+          <p:cNvPr id="11" name="rail-line"/>
           <p:cNvSpPr/>
           <p:nvPr/>
         </p:nvSpPr>
@@ -15275,7 +14629,7 @@
       </p:sp>
       <p:sp>
         <p:nvSpPr>
-          <p:cNvPr id="13" name="rail-dot-1"/>
+          <p:cNvPr id="12" name="rail-dot-1"/>
           <p:cNvSpPr/>
           <p:nvPr/>
         </p:nvSpPr>
@@ -15306,7 +14660,7 @@
       </p:sp>
       <p:sp>
         <p:nvSpPr>
-          <p:cNvPr id="14" name="rail-num-1"/>
+          <p:cNvPr id="13" name="rail-num-1"/>
           <p:cNvSpPr txBox="1"/>
           <p:nvPr/>
         </p:nvSpPr>
@@ -15341,7 +14695,7 @@
       </p:sp>
       <p:sp>
         <p:nvSpPr>
-          <p:cNvPr id="15" name="rail-dot-2"/>
+          <p:cNvPr id="14" name="rail-dot-2"/>
           <p:cNvSpPr/>
           <p:nvPr/>
         </p:nvSpPr>
@@ -15372,7 +14726,7 @@
       </p:sp>
       <p:sp>
         <p:nvSpPr>
-          <p:cNvPr id="16" name="rail-num-2"/>
+          <p:cNvPr id="15" name="rail-num-2"/>
           <p:cNvSpPr txBox="1"/>
           <p:nvPr/>
         </p:nvSpPr>
@@ -15407,7 +14761,7 @@
       </p:sp>
       <p:sp>
         <p:nvSpPr>
-          <p:cNvPr id="17" name="rail-dot-3"/>
+          <p:cNvPr id="16" name="rail-dot-3"/>
           <p:cNvSpPr/>
           <p:nvPr/>
         </p:nvSpPr>
@@ -15438,7 +14792,7 @@
       </p:sp>
       <p:sp>
         <p:nvSpPr>
-          <p:cNvPr id="18" name="rail-num-3"/>
+          <p:cNvPr id="17" name="rail-num-3"/>
           <p:cNvSpPr txBox="1"/>
           <p:nvPr/>
         </p:nvSpPr>
@@ -15473,7 +14827,7 @@
       </p:sp>
       <p:sp>
         <p:nvSpPr>
-          <p:cNvPr id="19" name="rail-dot-4"/>
+          <p:cNvPr id="18" name="rail-dot-4"/>
           <p:cNvSpPr/>
           <p:nvPr/>
         </p:nvSpPr>
@@ -15504,7 +14858,7 @@
       </p:sp>
       <p:sp>
         <p:nvSpPr>
-          <p:cNvPr id="20" name="rail-num-4"/>
+          <p:cNvPr id="19" name="rail-num-4"/>
           <p:cNvSpPr txBox="1"/>
           <p:nvPr/>
         </p:nvSpPr>
@@ -15539,7 +14893,7 @@
       </p:sp>
       <p:sp>
         <p:nvSpPr>
-          <p:cNvPr id="21" name="rail-dot-5"/>
+          <p:cNvPr id="20" name="rail-dot-5"/>
           <p:cNvSpPr/>
           <p:nvPr/>
         </p:nvSpPr>
@@ -15570,7 +14924,7 @@
       </p:sp>
       <p:sp>
         <p:nvSpPr>
-          <p:cNvPr id="22" name="rail-num-5"/>
+          <p:cNvPr id="21" name="rail-num-5"/>
           <p:cNvSpPr txBox="1"/>
           <p:nvPr/>
         </p:nvSpPr>

</xml_diff>